<commit_message>
update slides with code
</commit_message>
<xml_diff>
--- a/02Integration/99_slides_with_Rcode.pptx
+++ b/02Integration/99_slides_with_Rcode.pptx
@@ -12,6 +12,8 @@
     <p:sldId id="260" r:id="rId6"/>
     <p:sldId id="261" r:id="rId7"/>
     <p:sldId id="262" r:id="rId8"/>
+    <p:sldId id="263" r:id="rId9"/>
+    <p:sldId id="264" r:id="rId10"/>
   </p:sldIdLst>
   <p:sldSz cx="9144000" cy="5143500" type="screen16x9"/>
   <p:notesSz cx="6858000" cy="9144000"/>
@@ -3196,41 +3198,162 @@
             </a:pPr>
             <a:r>
               <a:rPr/>
-              <a:t>Outliers - one observation is isolated from the others</a:t>
-            </a:r>
-          </a:p>
-        </p:txBody>
-      </p:sp>
-      <p:pic>
-        <p:nvPicPr>
-          <p:cNvPr descr="99_slides_with_Rcode_files/figure-pptx/outlier%20-%20one%20weird%20value-1.png" id="0" name="Picture 1"/>
-          <p:cNvPicPr>
-            <a:picLocks noGrp="1" noChangeAspect="1"/>
-          </p:cNvPicPr>
-          <p:nvPr/>
-        </p:nvPicPr>
-        <p:blipFill>
-          <a:blip r:embed="rId2"/>
-          <a:stretch>
-            <a:fillRect/>
-          </a:stretch>
-        </p:blipFill>
-        <p:spPr bwMode="auto">
-          <a:xfrm>
-            <a:off x="1181100" y="1193800"/>
-            <a:ext cx="6781800" cy="3390900"/>
-          </a:xfrm>
-          <a:prstGeom prst="rect">
-            <a:avLst/>
-          </a:prstGeom>
-          <a:noFill/>
-          <a:ln w="9525">
-            <a:noFill/>
-            <a:headEnd/>
-            <a:tailEnd/>
-          </a:ln>
-        </p:spPr>
-      </p:pic>
+              <a:t>Parcimonie</a:t>
+            </a:r>
+          </a:p>
+        </p:txBody>
+      </p:sp>
+      <p:sp>
+        <p:nvSpPr>
+          <p:cNvPr id="3" name="Content Placeholder 2"/>
+          <p:cNvSpPr>
+            <a:spLocks noGrp="1"/>
+          </p:cNvSpPr>
+          <p:nvPr>
+            <p:ph idx="1"/>
+          </p:nvPr>
+        </p:nvSpPr>
+        <p:spPr/>
+        <p:txBody>
+          <a:bodyPr/>
+          <a:lstStyle/>
+          <a:p>
+            <a:pPr lvl="0" indent="0">
+              <a:buNone/>
+            </a:pPr>
+            <a:r>
+              <a:rPr>
+                <a:solidFill>
+                  <a:srgbClr val="003B4F"/>
+                </a:solidFill>
+                <a:latin typeface="Courier"/>
+              </a:rPr>
+              <a:t>random_sparsity &lt;- </a:t>
+            </a:r>
+            <a:r>
+              <a:rPr b="1">
+                <a:solidFill>
+                  <a:srgbClr val="003B4F"/>
+                </a:solidFill>
+                <a:latin typeface="Courier"/>
+              </a:rPr>
+              <a:t>function</a:t>
+            </a:r>
+            <a:r>
+              <a:rPr>
+                <a:solidFill>
+                  <a:srgbClr val="003B4F"/>
+                </a:solidFill>
+                <a:latin typeface="Courier"/>
+              </a:rPr>
+              <a:t>(coefs, nb) {</a:t>
+            </a:r>
+            <a:br/>
+            <a:r>
+              <a:rPr>
+                <a:solidFill>
+                  <a:srgbClr val="003B4F"/>
+                </a:solidFill>
+                <a:latin typeface="Courier"/>
+              </a:rPr>
+              <a:t>  out &lt;- coefs</a:t>
+            </a:r>
+            <a:br/>
+            <a:r>
+              <a:rPr>
+                <a:solidFill>
+                  <a:srgbClr val="003B4F"/>
+                </a:solidFill>
+                <a:latin typeface="Courier"/>
+              </a:rPr>
+              <a:t>  out[</a:t>
+            </a:r>
+            <a:r>
+              <a:rPr>
+                <a:solidFill>
+                  <a:srgbClr val="4758AB"/>
+                </a:solidFill>
+                <a:latin typeface="Courier"/>
+              </a:rPr>
+              <a:t>sample</a:t>
+            </a:r>
+            <a:r>
+              <a:rPr>
+                <a:solidFill>
+                  <a:srgbClr val="003B4F"/>
+                </a:solidFill>
+                <a:latin typeface="Courier"/>
+              </a:rPr>
+              <a:t>(</a:t>
+            </a:r>
+            <a:r>
+              <a:rPr>
+                <a:solidFill>
+                  <a:srgbClr val="4758AB"/>
+                </a:solidFill>
+                <a:latin typeface="Courier"/>
+              </a:rPr>
+              <a:t>length</a:t>
+            </a:r>
+            <a:r>
+              <a:rPr>
+                <a:solidFill>
+                  <a:srgbClr val="003B4F"/>
+                </a:solidFill>
+                <a:latin typeface="Courier"/>
+              </a:rPr>
+              <a:t>(out, nb))] &lt;- </a:t>
+            </a:r>
+            <a:r>
+              <a:rPr>
+                <a:solidFill>
+                  <a:srgbClr val="AD0000"/>
+                </a:solidFill>
+                <a:latin typeface="Courier"/>
+              </a:rPr>
+              <a:t>0</a:t>
+            </a:r>
+            <a:br/>
+            <a:r>
+              <a:rPr>
+                <a:solidFill>
+                  <a:srgbClr val="003B4F"/>
+                </a:solidFill>
+                <a:latin typeface="Courier"/>
+              </a:rPr>
+              <a:t>  </a:t>
+            </a:r>
+            <a:r>
+              <a:rPr>
+                <a:solidFill>
+                  <a:srgbClr val="4758AB"/>
+                </a:solidFill>
+                <a:latin typeface="Courier"/>
+              </a:rPr>
+              <a:t>return</a:t>
+            </a:r>
+            <a:r>
+              <a:rPr>
+                <a:solidFill>
+                  <a:srgbClr val="003B4F"/>
+                </a:solidFill>
+                <a:latin typeface="Courier"/>
+              </a:rPr>
+              <a:t>(out)</a:t>
+            </a:r>
+            <a:br/>
+            <a:r>
+              <a:rPr>
+                <a:solidFill>
+                  <a:srgbClr val="003B4F"/>
+                </a:solidFill>
+                <a:latin typeface="Courier"/>
+              </a:rPr>
+              <a:t>}</a:t>
+            </a:r>
+          </a:p>
+        </p:txBody>
+      </p:sp>
     </p:spTree>
   </p:cSld>
 </p:sld>
@@ -3273,41 +3396,233 @@
             </a:pPr>
             <a:r>
               <a:rPr/>
-              <a:t>Outliers - carte très dissymétrique</a:t>
-            </a:r>
-          </a:p>
-        </p:txBody>
-      </p:sp>
-      <p:pic>
-        <p:nvPicPr>
-          <p:cNvPr descr="99_slides_with_Rcode_files/figure-pptx/outlier%20-%20assymetrical%20map-1.png" id="0" name="Picture 1"/>
-          <p:cNvPicPr>
-            <a:picLocks noGrp="1" noChangeAspect="1"/>
-          </p:cNvPicPr>
-          <p:nvPr/>
-        </p:nvPicPr>
-        <p:blipFill>
-          <a:blip r:embed="rId2"/>
-          <a:stretch>
-            <a:fillRect/>
-          </a:stretch>
-        </p:blipFill>
-        <p:spPr bwMode="auto">
-          <a:xfrm>
-            <a:off x="1181100" y="1193800"/>
-            <a:ext cx="6781800" cy="3390900"/>
-          </a:xfrm>
-          <a:prstGeom prst="rect">
-            <a:avLst/>
-          </a:prstGeom>
-          <a:noFill/>
-          <a:ln w="9525">
-            <a:noFill/>
-            <a:headEnd/>
-            <a:tailEnd/>
-          </a:ln>
-        </p:spPr>
-      </p:pic>
+              <a:t>SGCCA</a:t>
+            </a:r>
+          </a:p>
+        </p:txBody>
+      </p:sp>
+      <p:sp>
+        <p:nvSpPr>
+          <p:cNvPr id="3" name="Content Placeholder 2"/>
+          <p:cNvSpPr>
+            <a:spLocks noGrp="1"/>
+          </p:cNvSpPr>
+          <p:nvPr>
+            <p:ph idx="1"/>
+          </p:nvPr>
+        </p:nvSpPr>
+        <p:spPr/>
+        <p:txBody>
+          <a:bodyPr/>
+          <a:lstStyle/>
+          <a:p>
+            <a:pPr lvl="0" indent="0">
+              <a:buNone/>
+            </a:pPr>
+            <a:r>
+              <a:rPr>
+                <a:solidFill>
+                  <a:srgbClr val="003B4F"/>
+                </a:solidFill>
+                <a:latin typeface="Courier"/>
+              </a:rPr>
+              <a:t>res.sgcca &lt;- </a:t>
+            </a:r>
+            <a:r>
+              <a:rPr>
+                <a:solidFill>
+                  <a:srgbClr val="4758AB"/>
+                </a:solidFill>
+                <a:latin typeface="Courier"/>
+              </a:rPr>
+              <a:t>rgcca</a:t>
+            </a:r>
+            <a:r>
+              <a:rPr>
+                <a:solidFill>
+                  <a:srgbClr val="003B4F"/>
+                </a:solidFill>
+                <a:latin typeface="Courier"/>
+              </a:rPr>
+              <a:t>(</a:t>
+            </a:r>
+            <a:br/>
+            <a:r>
+              <a:rPr>
+                <a:solidFill>
+                  <a:srgbClr val="003B4F"/>
+                </a:solidFill>
+                <a:latin typeface="Courier"/>
+              </a:rPr>
+              <a:t>  </a:t>
+            </a:r>
+            <a:r>
+              <a:rPr>
+                <a:solidFill>
+                  <a:srgbClr val="657422"/>
+                </a:solidFill>
+                <a:latin typeface="Courier"/>
+              </a:rPr>
+              <a:t>blocks =</a:t>
+            </a:r>
+            <a:r>
+              <a:rPr>
+                <a:solidFill>
+                  <a:srgbClr val="003B4F"/>
+                </a:solidFill>
+                <a:latin typeface="Courier"/>
+              </a:rPr>
+              <a:t> pHGG,</a:t>
+            </a:r>
+            <a:br/>
+            <a:r>
+              <a:rPr>
+                <a:solidFill>
+                  <a:srgbClr val="003B4F"/>
+                </a:solidFill>
+                <a:latin typeface="Courier"/>
+              </a:rPr>
+              <a:t>  </a:t>
+            </a:r>
+            <a:r>
+              <a:rPr>
+                <a:solidFill>
+                  <a:srgbClr val="657422"/>
+                </a:solidFill>
+                <a:latin typeface="Courier"/>
+              </a:rPr>
+              <a:t>sparsity =</a:t>
+            </a:r>
+            <a:r>
+              <a:rPr>
+                <a:solidFill>
+                  <a:srgbClr val="003B4F"/>
+                </a:solidFill>
+                <a:latin typeface="Courier"/>
+              </a:rPr>
+              <a:t> </a:t>
+            </a:r>
+            <a:r>
+              <a:rPr>
+                <a:solidFill>
+                  <a:srgbClr val="4758AB"/>
+                </a:solidFill>
+                <a:latin typeface="Courier"/>
+              </a:rPr>
+              <a:t>c</a:t>
+            </a:r>
+            <a:r>
+              <a:rPr>
+                <a:solidFill>
+                  <a:srgbClr val="003B4F"/>
+                </a:solidFill>
+                <a:latin typeface="Courier"/>
+              </a:rPr>
+              <a:t>(</a:t>
+            </a:r>
+            <a:r>
+              <a:rPr>
+                <a:solidFill>
+                  <a:srgbClr val="AD0000"/>
+                </a:solidFill>
+                <a:latin typeface="Courier"/>
+              </a:rPr>
+              <a:t>0.1</a:t>
+            </a:r>
+            <a:r>
+              <a:rPr>
+                <a:solidFill>
+                  <a:srgbClr val="003B4F"/>
+                </a:solidFill>
+                <a:latin typeface="Courier"/>
+              </a:rPr>
+              <a:t>, </a:t>
+            </a:r>
+            <a:r>
+              <a:rPr>
+                <a:solidFill>
+                  <a:srgbClr val="AD0000"/>
+                </a:solidFill>
+                <a:latin typeface="Courier"/>
+              </a:rPr>
+              <a:t>0.1</a:t>
+            </a:r>
+            <a:r>
+              <a:rPr>
+                <a:solidFill>
+                  <a:srgbClr val="003B4F"/>
+                </a:solidFill>
+                <a:latin typeface="Courier"/>
+              </a:rPr>
+              <a:t>, </a:t>
+            </a:r>
+            <a:r>
+              <a:rPr>
+                <a:solidFill>
+                  <a:srgbClr val="AD0000"/>
+                </a:solidFill>
+                <a:latin typeface="Courier"/>
+              </a:rPr>
+              <a:t>1</a:t>
+            </a:r>
+            <a:r>
+              <a:rPr>
+                <a:solidFill>
+                  <a:srgbClr val="003B4F"/>
+                </a:solidFill>
+                <a:latin typeface="Courier"/>
+              </a:rPr>
+              <a:t>),</a:t>
+            </a:r>
+            <a:br/>
+            <a:r>
+              <a:rPr>
+                <a:solidFill>
+                  <a:srgbClr val="003B4F"/>
+                </a:solidFill>
+                <a:latin typeface="Courier"/>
+              </a:rPr>
+              <a:t>  </a:t>
+            </a:r>
+            <a:r>
+              <a:rPr>
+                <a:solidFill>
+                  <a:srgbClr val="657422"/>
+                </a:solidFill>
+                <a:latin typeface="Courier"/>
+              </a:rPr>
+              <a:t>response =</a:t>
+            </a:r>
+            <a:r>
+              <a:rPr>
+                <a:solidFill>
+                  <a:srgbClr val="003B4F"/>
+                </a:solidFill>
+                <a:latin typeface="Courier"/>
+              </a:rPr>
+              <a:t> </a:t>
+            </a:r>
+            <a:r>
+              <a:rPr>
+                <a:solidFill>
+                  <a:srgbClr val="AD0000"/>
+                </a:solidFill>
+                <a:latin typeface="Courier"/>
+              </a:rPr>
+              <a:t>3</a:t>
+            </a:r>
+            <a:r>
+              <a:rPr>
+                <a:solidFill>
+                  <a:srgbClr val="003B4F"/>
+                </a:solidFill>
+                <a:latin typeface="Courier"/>
+              </a:rPr>
+              <a:t>)</a:t>
+            </a:r>
+          </a:p>
+        </p:txBody>
+      </p:sp>
     </p:spTree>
   </p:cSld>
 </p:sld>
@@ -3350,14 +3665,14 @@
             </a:pPr>
             <a:r>
               <a:rPr/>
-              <a:t>Outliers - confusion</a:t>
+              <a:t>Outliers - one observation is isolated from the others</a:t>
             </a:r>
           </a:p>
         </p:txBody>
       </p:sp>
       <p:pic>
         <p:nvPicPr>
-          <p:cNvPr descr="99_slides_with_Rcode_files/figure-pptx/outlier%20-%20confusion-1.png" id="0" name="Picture 1"/>
+          <p:cNvPr descr="99_slides_with_Rcode_files/figure-pptx/outlier%20-%20one%20weird%20value-1.png" id="0" name="Picture 1"/>
           <p:cNvPicPr>
             <a:picLocks noGrp="1" noChangeAspect="1"/>
           </p:cNvPicPr>
@@ -3427,14 +3742,14 @@
             </a:pPr>
             <a:r>
               <a:rPr/>
-              <a:t>Sélection du nombre de composantes</a:t>
+              <a:t>Outliers - carte très dissymétrique</a:t>
             </a:r>
           </a:p>
         </p:txBody>
       </p:sp>
       <p:pic>
         <p:nvPicPr>
-          <p:cNvPr descr="99_slides_with_Rcode_files/figure-pptx/nb%20components-1.png" id="0" name="Picture 1"/>
+          <p:cNvPr descr="99_slides_with_Rcode_files/figure-pptx/outlier%20-%20assymetrical%20map-1.png" id="0" name="Picture 1"/>
           <p:cNvPicPr>
             <a:picLocks noGrp="1" noChangeAspect="1"/>
           </p:cNvPicPr>
@@ -3504,6 +3819,160 @@
             </a:pPr>
             <a:r>
               <a:rPr/>
+              <a:t>Outliers - confusion</a:t>
+            </a:r>
+          </a:p>
+        </p:txBody>
+      </p:sp>
+      <p:pic>
+        <p:nvPicPr>
+          <p:cNvPr descr="99_slides_with_Rcode_files/figure-pptx/outlier%20-%20confusion-1.png" id="0" name="Picture 1"/>
+          <p:cNvPicPr>
+            <a:picLocks noGrp="1" noChangeAspect="1"/>
+          </p:cNvPicPr>
+          <p:nvPr/>
+        </p:nvPicPr>
+        <p:blipFill>
+          <a:blip r:embed="rId2"/>
+          <a:stretch>
+            <a:fillRect/>
+          </a:stretch>
+        </p:blipFill>
+        <p:spPr bwMode="auto">
+          <a:xfrm>
+            <a:off x="1181100" y="1193800"/>
+            <a:ext cx="6781800" cy="3390900"/>
+          </a:xfrm>
+          <a:prstGeom prst="rect">
+            <a:avLst/>
+          </a:prstGeom>
+          <a:noFill/>
+          <a:ln w="9525">
+            <a:noFill/>
+            <a:headEnd/>
+            <a:tailEnd/>
+          </a:ln>
+        </p:spPr>
+      </p:pic>
+    </p:spTree>
+  </p:cSld>
+</p:sld>
+</file>
+
+<file path=ppt/slides/slide7.xml><?xml version="1.0" encoding="utf-8"?>
+<p:sld xmlns:a="http://schemas.openxmlformats.org/drawingml/2006/main" xmlns:r="http://schemas.openxmlformats.org/officeDocument/2006/relationships" xmlns:p="http://schemas.openxmlformats.org/presentationml/2006/main">
+  <p:cSld>
+    <p:spTree>
+      <p:nvGrpSpPr>
+        <p:cNvPr id="1" name=""/>
+        <p:cNvGrpSpPr/>
+        <p:nvPr/>
+      </p:nvGrpSpPr>
+      <p:grpSpPr>
+        <a:xfrm>
+          <a:off x="0" y="0"/>
+          <a:ext cx="0" cy="0"/>
+          <a:chOff x="0" y="0"/>
+          <a:chExt cx="0" cy="0"/>
+        </a:xfrm>
+      </p:grpSpPr>
+      <p:sp>
+        <p:nvSpPr>
+          <p:cNvPr id="2" name="Title 1"/>
+          <p:cNvSpPr>
+            <a:spLocks noGrp="1"/>
+          </p:cNvSpPr>
+          <p:nvPr>
+            <p:ph type="title"/>
+          </p:nvPr>
+        </p:nvSpPr>
+        <p:spPr/>
+        <p:txBody>
+          <a:bodyPr/>
+          <a:lstStyle/>
+          <a:p>
+            <a:pPr lvl="0" indent="0" marL="0">
+              <a:buNone/>
+            </a:pPr>
+            <a:r>
+              <a:rPr/>
+              <a:t>Sélection du nombre de composantes</a:t>
+            </a:r>
+          </a:p>
+        </p:txBody>
+      </p:sp>
+      <p:pic>
+        <p:nvPicPr>
+          <p:cNvPr descr="99_slides_with_Rcode_files/figure-pptx/nb%20components-1.png" id="0" name="Picture 1"/>
+          <p:cNvPicPr>
+            <a:picLocks noGrp="1" noChangeAspect="1"/>
+          </p:cNvPicPr>
+          <p:nvPr/>
+        </p:nvPicPr>
+        <p:blipFill>
+          <a:blip r:embed="rId2"/>
+          <a:stretch>
+            <a:fillRect/>
+          </a:stretch>
+        </p:blipFill>
+        <p:spPr bwMode="auto">
+          <a:xfrm>
+            <a:off x="1181100" y="1193800"/>
+            <a:ext cx="6781800" cy="3390900"/>
+          </a:xfrm>
+          <a:prstGeom prst="rect">
+            <a:avLst/>
+          </a:prstGeom>
+          <a:noFill/>
+          <a:ln w="9525">
+            <a:noFill/>
+            <a:headEnd/>
+            <a:tailEnd/>
+          </a:ln>
+        </p:spPr>
+      </p:pic>
+    </p:spTree>
+  </p:cSld>
+</p:sld>
+</file>
+
+<file path=ppt/slides/slide8.xml><?xml version="1.0" encoding="utf-8"?>
+<p:sld xmlns:a="http://schemas.openxmlformats.org/drawingml/2006/main" xmlns:r="http://schemas.openxmlformats.org/officeDocument/2006/relationships" xmlns:p="http://schemas.openxmlformats.org/presentationml/2006/main">
+  <p:cSld>
+    <p:spTree>
+      <p:nvGrpSpPr>
+        <p:cNvPr id="1" name=""/>
+        <p:cNvGrpSpPr/>
+        <p:nvPr/>
+      </p:nvGrpSpPr>
+      <p:grpSpPr>
+        <a:xfrm>
+          <a:off x="0" y="0"/>
+          <a:ext cx="0" cy="0"/>
+          <a:chOff x="0" y="0"/>
+          <a:chExt cx="0" cy="0"/>
+        </a:xfrm>
+      </p:grpSpPr>
+      <p:sp>
+        <p:nvSpPr>
+          <p:cNvPr id="2" name="Title 1"/>
+          <p:cNvSpPr>
+            <a:spLocks noGrp="1"/>
+          </p:cNvSpPr>
+          <p:nvPr>
+            <p:ph type="title"/>
+          </p:nvPr>
+        </p:nvSpPr>
+        <p:spPr/>
+        <p:txBody>
+          <a:bodyPr/>
+          <a:lstStyle/>
+          <a:p>
+            <a:pPr lvl="0" indent="0" marL="0">
+              <a:buNone/>
+            </a:pPr>
+            <a:r>
+              <a:rPr/>
               <a:t>Elbow rule</a:t>
             </a:r>
           </a:p>
@@ -3544,7 +4013,7 @@
 </p:sld>
 </file>
 
-<file path=ppt/slides/slide7.xml><?xml version="1.0" encoding="utf-8"?>
+<file path=ppt/slides/slide9.xml><?xml version="1.0" encoding="utf-8"?>
 <p:sld xmlns:a="http://schemas.openxmlformats.org/drawingml/2006/main" xmlns:r="http://schemas.openxmlformats.org/officeDocument/2006/relationships" xmlns:p="http://schemas.openxmlformats.org/presentationml/2006/main">
   <p:cSld>
     <p:spTree>

</xml_diff>